<commit_message>
update assemblage + LaTeX + Poster
</commit_message>
<xml_diff>
--- a/POSTER.pptx
+++ b/POSTER.pptx
@@ -178,7 +178,7 @@
 <file path=ppt/revisionInfo.xml><?xml version="1.0" encoding="utf-8"?>
 <p1510:revInfo xmlns:a="http://schemas.openxmlformats.org/drawingml/2006/main" xmlns:r="http://schemas.openxmlformats.org/officeDocument/2006/relationships" xmlns:p1510="http://schemas.microsoft.com/office/powerpoint/2015/10/main">
   <p1510:revLst>
-    <p1510:client id="{852B4C0F-FB6B-4FF3-8362-74B7577A66B1}" v="15" dt="2025-07-07T08:49:46.375"/>
+    <p1510:client id="{852B4C0F-FB6B-4FF3-8362-74B7577A66B1}" v="171" dt="2025-07-07T15:21:24.052"/>
   </p1510:revLst>
 </p1510:revInfo>
 </file>
@@ -188,16 +188,24 @@
   <pc:docChgLst>
     <pc:chgData name="Julien Sagnes" userId="949be203fa37cc39" providerId="LiveId" clId="{852B4C0F-FB6B-4FF3-8362-74B7577A66B1}"/>
     <pc:docChg chg="undo redo custSel modSld addSection">
-      <pc:chgData name="Julien Sagnes" userId="949be203fa37cc39" providerId="LiveId" clId="{852B4C0F-FB6B-4FF3-8362-74B7577A66B1}" dt="2025-07-07T08:50:07.319" v="2423" actId="1076"/>
+      <pc:chgData name="Julien Sagnes" userId="949be203fa37cc39" providerId="LiveId" clId="{852B4C0F-FB6B-4FF3-8362-74B7577A66B1}" dt="2025-07-07T15:21:36.409" v="4831" actId="1076"/>
       <pc:docMkLst>
         <pc:docMk/>
       </pc:docMkLst>
       <pc:sldChg chg="addSp delSp modSp mod modCm">
-        <pc:chgData name="Julien Sagnes" userId="949be203fa37cc39" providerId="LiveId" clId="{852B4C0F-FB6B-4FF3-8362-74B7577A66B1}" dt="2025-07-07T08:50:07.319" v="2423" actId="1076"/>
+        <pc:chgData name="Julien Sagnes" userId="949be203fa37cc39" providerId="LiveId" clId="{852B4C0F-FB6B-4FF3-8362-74B7577A66B1}" dt="2025-07-07T15:21:36.409" v="4831" actId="1076"/>
         <pc:sldMkLst>
           <pc:docMk/>
           <pc:sldMk cId="0" sldId="256"/>
         </pc:sldMkLst>
+        <pc:spChg chg="add mod">
+          <ac:chgData name="Julien Sagnes" userId="949be203fa37cc39" providerId="LiveId" clId="{852B4C0F-FB6B-4FF3-8362-74B7577A66B1}" dt="2025-07-07T14:39:16.796" v="4742" actId="20577"/>
+          <ac:spMkLst>
+            <pc:docMk/>
+            <pc:sldMk cId="0" sldId="256"/>
+            <ac:spMk id="2" creationId="{4C9C7473-640D-E58C-360B-62ED61A225AD}"/>
+          </ac:spMkLst>
+        </pc:spChg>
         <pc:spChg chg="add del mod">
           <ac:chgData name="Julien Sagnes" userId="949be203fa37cc39" providerId="LiveId" clId="{852B4C0F-FB6B-4FF3-8362-74B7577A66B1}" dt="2025-07-07T08:47:29.168" v="2361" actId="478"/>
           <ac:spMkLst>
@@ -207,7 +215,7 @@
           </ac:spMkLst>
         </pc:spChg>
         <pc:spChg chg="add mod">
-          <ac:chgData name="Julien Sagnes" userId="949be203fa37cc39" providerId="LiveId" clId="{852B4C0F-FB6B-4FF3-8362-74B7577A66B1}" dt="2025-07-04T08:56:36.737" v="619" actId="208"/>
+          <ac:chgData name="Julien Sagnes" userId="949be203fa37cc39" providerId="LiveId" clId="{852B4C0F-FB6B-4FF3-8362-74B7577A66B1}" dt="2025-07-07T14:05:58.823" v="4358" actId="20577"/>
           <ac:spMkLst>
             <pc:docMk/>
             <pc:sldMk cId="0" sldId="256"/>
@@ -215,7 +223,7 @@
           </ac:spMkLst>
         </pc:spChg>
         <pc:spChg chg="add mod">
-          <ac:chgData name="Julien Sagnes" userId="949be203fa37cc39" providerId="LiveId" clId="{852B4C0F-FB6B-4FF3-8362-74B7577A66B1}" dt="2025-07-07T08:05:47.533" v="1392" actId="113"/>
+          <ac:chgData name="Julien Sagnes" userId="949be203fa37cc39" providerId="LiveId" clId="{852B4C0F-FB6B-4FF3-8362-74B7577A66B1}" dt="2025-07-07T14:06:25.024" v="4377" actId="113"/>
           <ac:spMkLst>
             <pc:docMk/>
             <pc:sldMk cId="0" sldId="256"/>
@@ -231,7 +239,7 @@
           </ac:spMkLst>
         </pc:spChg>
         <pc:spChg chg="add mod">
-          <ac:chgData name="Julien Sagnes" userId="949be203fa37cc39" providerId="LiveId" clId="{852B4C0F-FB6B-4FF3-8362-74B7577A66B1}" dt="2025-07-07T08:47:59.959" v="2365" actId="14100"/>
+          <ac:chgData name="Julien Sagnes" userId="949be203fa37cc39" providerId="LiveId" clId="{852B4C0F-FB6B-4FF3-8362-74B7577A66B1}" dt="2025-07-07T14:43:48.910" v="4821" actId="14100"/>
           <ac:spMkLst>
             <pc:docMk/>
             <pc:sldMk cId="0" sldId="256"/>
@@ -239,7 +247,7 @@
           </ac:spMkLst>
         </pc:spChg>
         <pc:spChg chg="add mod">
-          <ac:chgData name="Julien Sagnes" userId="949be203fa37cc39" providerId="LiveId" clId="{852B4C0F-FB6B-4FF3-8362-74B7577A66B1}" dt="2025-07-07T08:49:09.949" v="2387" actId="1076"/>
+          <ac:chgData name="Julien Sagnes" userId="949be203fa37cc39" providerId="LiveId" clId="{852B4C0F-FB6B-4FF3-8362-74B7577A66B1}" dt="2025-07-07T13:57:33.782" v="4121" actId="207"/>
           <ac:spMkLst>
             <pc:docMk/>
             <pc:sldMk cId="0" sldId="256"/>
@@ -247,7 +255,7 @@
           </ac:spMkLst>
         </pc:spChg>
         <pc:spChg chg="add mod">
-          <ac:chgData name="Julien Sagnes" userId="949be203fa37cc39" providerId="LiveId" clId="{852B4C0F-FB6B-4FF3-8362-74B7577A66B1}" dt="2025-07-07T08:50:07.319" v="2423" actId="1076"/>
+          <ac:chgData name="Julien Sagnes" userId="949be203fa37cc39" providerId="LiveId" clId="{852B4C0F-FB6B-4FF3-8362-74B7577A66B1}" dt="2025-07-07T14:38:44.823" v="4707" actId="1076"/>
           <ac:spMkLst>
             <pc:docMk/>
             <pc:sldMk cId="0" sldId="256"/>
@@ -263,7 +271,47 @@
           </ac:spMkLst>
         </pc:spChg>
         <pc:spChg chg="add mod">
-          <ac:chgData name="Julien Sagnes" userId="949be203fa37cc39" providerId="LiveId" clId="{852B4C0F-FB6B-4FF3-8362-74B7577A66B1}" dt="2025-07-07T08:47:51.729" v="2364" actId="14100"/>
+          <ac:chgData name="Julien Sagnes" userId="949be203fa37cc39" providerId="LiveId" clId="{852B4C0F-FB6B-4FF3-8362-74B7577A66B1}" dt="2025-07-07T11:44:20.036" v="2703" actId="14100"/>
+          <ac:spMkLst>
+            <pc:docMk/>
+            <pc:sldMk cId="0" sldId="256"/>
+            <ac:spMk id="17" creationId="{54216D39-8C29-866D-D82F-374F32776D62}"/>
+          </ac:spMkLst>
+        </pc:spChg>
+        <pc:spChg chg="add del mod">
+          <ac:chgData name="Julien Sagnes" userId="949be203fa37cc39" providerId="LiveId" clId="{852B4C0F-FB6B-4FF3-8362-74B7577A66B1}" dt="2025-07-07T13:05:55.192" v="3126"/>
+          <ac:spMkLst>
+            <pc:docMk/>
+            <pc:sldMk cId="0" sldId="256"/>
+            <ac:spMk id="20" creationId="{F39EB652-561E-391E-5688-A2090C6A505E}"/>
+          </ac:spMkLst>
+        </pc:spChg>
+        <pc:spChg chg="add del mod">
+          <ac:chgData name="Julien Sagnes" userId="949be203fa37cc39" providerId="LiveId" clId="{852B4C0F-FB6B-4FF3-8362-74B7577A66B1}" dt="2025-07-07T13:11:23.420" v="3294" actId="478"/>
+          <ac:spMkLst>
+            <pc:docMk/>
+            <pc:sldMk cId="0" sldId="256"/>
+            <ac:spMk id="21" creationId="{BCF98FF6-1DC7-07C9-CA98-2E3F2E95EF99}"/>
+          </ac:spMkLst>
+        </pc:spChg>
+        <pc:spChg chg="add mod">
+          <ac:chgData name="Julien Sagnes" userId="949be203fa37cc39" providerId="LiveId" clId="{852B4C0F-FB6B-4FF3-8362-74B7577A66B1}" dt="2025-07-07T13:11:49.985" v="3361" actId="20578"/>
+          <ac:spMkLst>
+            <pc:docMk/>
+            <pc:sldMk cId="0" sldId="256"/>
+            <ac:spMk id="22" creationId="{79955613-CD37-F288-8B6B-803F909EF8C3}"/>
+          </ac:spMkLst>
+        </pc:spChg>
+        <pc:spChg chg="add mod">
+          <ac:chgData name="Julien Sagnes" userId="949be203fa37cc39" providerId="LiveId" clId="{852B4C0F-FB6B-4FF3-8362-74B7577A66B1}" dt="2025-07-07T14:23:13.039" v="4594" actId="1076"/>
+          <ac:spMkLst>
+            <pc:docMk/>
+            <pc:sldMk cId="0" sldId="256"/>
+            <ac:spMk id="23" creationId="{BFFE58B0-2AE4-1EB6-82C0-94306E5923C3}"/>
+          </ac:spMkLst>
+        </pc:spChg>
+        <pc:spChg chg="add mod">
+          <ac:chgData name="Julien Sagnes" userId="949be203fa37cc39" providerId="LiveId" clId="{852B4C0F-FB6B-4FF3-8362-74B7577A66B1}" dt="2025-07-07T14:43:35.608" v="4818" actId="14100"/>
           <ac:spMkLst>
             <pc:docMk/>
             <pc:sldMk cId="0" sldId="256"/>
@@ -271,7 +319,7 @@
           </ac:spMkLst>
         </pc:spChg>
         <pc:spChg chg="add mod">
-          <ac:chgData name="Julien Sagnes" userId="949be203fa37cc39" providerId="LiveId" clId="{852B4C0F-FB6B-4FF3-8362-74B7577A66B1}" dt="2025-07-04T09:49:27.592" v="1306" actId="1076"/>
+          <ac:chgData name="Julien Sagnes" userId="949be203fa37cc39" providerId="LiveId" clId="{852B4C0F-FB6B-4FF3-8362-74B7577A66B1}" dt="2025-07-07T13:57:37.238" v="4122" actId="207"/>
           <ac:spMkLst>
             <pc:docMk/>
             <pc:sldMk cId="0" sldId="256"/>
@@ -279,11 +327,75 @@
           </ac:spMkLst>
         </pc:spChg>
         <pc:spChg chg="add mod">
-          <ac:chgData name="Julien Sagnes" userId="949be203fa37cc39" providerId="LiveId" clId="{852B4C0F-FB6B-4FF3-8362-74B7577A66B1}" dt="2025-07-07T08:46:09.568" v="2353" actId="113"/>
+          <ac:chgData name="Julien Sagnes" userId="949be203fa37cc39" providerId="LiveId" clId="{852B4C0F-FB6B-4FF3-8362-74B7577A66B1}" dt="2025-07-07T14:22:42.024" v="4530" actId="113"/>
           <ac:spMkLst>
             <pc:docMk/>
             <pc:sldMk cId="0" sldId="256"/>
             <ac:spMk id="33" creationId="{BA1C820A-E9D3-5B2C-E539-750AAEAFC3B6}"/>
+          </ac:spMkLst>
+        </pc:spChg>
+        <pc:spChg chg="add mod">
+          <ac:chgData name="Julien Sagnes" userId="949be203fa37cc39" providerId="LiveId" clId="{852B4C0F-FB6B-4FF3-8362-74B7577A66B1}" dt="2025-07-07T14:44:00.263" v="4823" actId="1076"/>
+          <ac:spMkLst>
+            <pc:docMk/>
+            <pc:sldMk cId="0" sldId="256"/>
+            <ac:spMk id="35" creationId="{B692489C-6999-4008-6318-75D2BE9E4648}"/>
+          </ac:spMkLst>
+        </pc:spChg>
+        <pc:spChg chg="add mod">
+          <ac:chgData name="Julien Sagnes" userId="949be203fa37cc39" providerId="LiveId" clId="{852B4C0F-FB6B-4FF3-8362-74B7577A66B1}" dt="2025-07-07T14:42:45.215" v="4812" actId="14100"/>
+          <ac:spMkLst>
+            <pc:docMk/>
+            <pc:sldMk cId="0" sldId="256"/>
+            <ac:spMk id="36" creationId="{EBF305C7-3B56-A639-5DDA-46A588EFA96A}"/>
+          </ac:spMkLst>
+        </pc:spChg>
+        <pc:spChg chg="add mod">
+          <ac:chgData name="Julien Sagnes" userId="949be203fa37cc39" providerId="LiveId" clId="{852B4C0F-FB6B-4FF3-8362-74B7577A66B1}" dt="2025-07-07T13:59:06.413" v="4135" actId="1076"/>
+          <ac:spMkLst>
+            <pc:docMk/>
+            <pc:sldMk cId="0" sldId="256"/>
+            <ac:spMk id="37" creationId="{93D53B09-F734-2CD2-A0FF-FA44CE0A3A64}"/>
+          </ac:spMkLst>
+        </pc:spChg>
+        <pc:spChg chg="add del">
+          <ac:chgData name="Julien Sagnes" userId="949be203fa37cc39" providerId="LiveId" clId="{852B4C0F-FB6B-4FF3-8362-74B7577A66B1}" dt="2025-07-07T14:19:45.445" v="4502" actId="478"/>
+          <ac:spMkLst>
+            <pc:docMk/>
+            <pc:sldMk cId="0" sldId="256"/>
+            <ac:spMk id="38" creationId="{355A654B-64F5-9FA3-3054-33DDBADE979C}"/>
+          </ac:spMkLst>
+        </pc:spChg>
+        <pc:spChg chg="add del mod">
+          <ac:chgData name="Julien Sagnes" userId="949be203fa37cc39" providerId="LiveId" clId="{852B4C0F-FB6B-4FF3-8362-74B7577A66B1}" dt="2025-07-07T14:20:06.065" v="4505" actId="478"/>
+          <ac:spMkLst>
+            <pc:docMk/>
+            <pc:sldMk cId="0" sldId="256"/>
+            <ac:spMk id="39" creationId="{232D2117-01ED-1DA0-DC86-6C126E5E9BB6}"/>
+          </ac:spMkLst>
+        </pc:spChg>
+        <pc:spChg chg="add del">
+          <ac:chgData name="Julien Sagnes" userId="949be203fa37cc39" providerId="LiveId" clId="{852B4C0F-FB6B-4FF3-8362-74B7577A66B1}" dt="2025-07-07T14:20:25.376" v="4507" actId="478"/>
+          <ac:spMkLst>
+            <pc:docMk/>
+            <pc:sldMk cId="0" sldId="256"/>
+            <ac:spMk id="40" creationId="{33A54096-2D53-EFA9-8D9B-90DB21CC2BEB}"/>
+          </ac:spMkLst>
+        </pc:spChg>
+        <pc:spChg chg="add mod">
+          <ac:chgData name="Julien Sagnes" userId="949be203fa37cc39" providerId="LiveId" clId="{852B4C0F-FB6B-4FF3-8362-74B7577A66B1}" dt="2025-07-07T14:43:54.717" v="4822" actId="14100"/>
+          <ac:spMkLst>
+            <pc:docMk/>
+            <pc:sldMk cId="0" sldId="256"/>
+            <ac:spMk id="41" creationId="{8A879908-B1D8-5540-1276-492476E3E355}"/>
+          </ac:spMkLst>
+        </pc:spChg>
+        <pc:spChg chg="add mod">
+          <ac:chgData name="Julien Sagnes" userId="949be203fa37cc39" providerId="LiveId" clId="{852B4C0F-FB6B-4FF3-8362-74B7577A66B1}" dt="2025-07-07T14:38:34.712" v="4705" actId="1076"/>
+          <ac:spMkLst>
+            <pc:docMk/>
+            <pc:sldMk cId="0" sldId="256"/>
+            <ac:spMk id="42" creationId="{095C6D14-6876-F156-24AD-C767534F60A2}"/>
           </ac:spMkLst>
         </pc:spChg>
         <pc:spChg chg="mod">
@@ -295,7 +407,7 @@
           </ac:spMkLst>
         </pc:spChg>
         <pc:spChg chg="mod">
-          <ac:chgData name="Julien Sagnes" userId="949be203fa37cc39" providerId="LiveId" clId="{852B4C0F-FB6B-4FF3-8362-74B7577A66B1}" dt="2025-07-07T08:50:00.315" v="2422" actId="1076"/>
+          <ac:chgData name="Julien Sagnes" userId="949be203fa37cc39" providerId="LiveId" clId="{852B4C0F-FB6B-4FF3-8362-74B7577A66B1}" dt="2025-07-07T14:38:43.664" v="4706" actId="1076"/>
           <ac:spMkLst>
             <pc:docMk/>
             <pc:sldMk cId="0" sldId="256"/>
@@ -310,12 +422,100 @@
             <ac:spMk id="2065" creationId="{00000000-0000-0000-0000-000000000000}"/>
           </ac:spMkLst>
         </pc:spChg>
+        <pc:grpChg chg="add mod">
+          <ac:chgData name="Julien Sagnes" userId="949be203fa37cc39" providerId="LiveId" clId="{852B4C0F-FB6B-4FF3-8362-74B7577A66B1}" dt="2025-07-07T14:04:35.482" v="4340" actId="1076"/>
+          <ac:grpSpMkLst>
+            <pc:docMk/>
+            <pc:sldMk cId="0" sldId="256"/>
+            <ac:grpSpMk id="18" creationId="{348806F0-6F60-247F-7A79-EB89F1B6FC0D}"/>
+          </ac:grpSpMkLst>
+        </pc:grpChg>
         <pc:picChg chg="mod">
           <ac:chgData name="Julien Sagnes" userId="949be203fa37cc39" providerId="LiveId" clId="{852B4C0F-FB6B-4FF3-8362-74B7577A66B1}" dt="2025-07-04T08:40:51.498" v="249" actId="1076"/>
           <ac:picMkLst>
             <pc:docMk/>
             <pc:sldMk cId="0" sldId="256"/>
             <ac:picMk id="5" creationId="{00000000-0000-0000-0000-000000000000}"/>
+          </ac:picMkLst>
+        </pc:picChg>
+        <pc:picChg chg="add del mod">
+          <ac:chgData name="Julien Sagnes" userId="949be203fa37cc39" providerId="LiveId" clId="{852B4C0F-FB6B-4FF3-8362-74B7577A66B1}" dt="2025-07-07T15:20:59.340" v="4825" actId="478"/>
+          <ac:picMkLst>
+            <pc:docMk/>
+            <pc:sldMk cId="0" sldId="256"/>
+            <ac:picMk id="12" creationId="{5D0B9F10-D36A-4802-6D6D-409752515B3A}"/>
+          </ac:picMkLst>
+        </pc:picChg>
+        <pc:picChg chg="add mod">
+          <ac:chgData name="Julien Sagnes" userId="949be203fa37cc39" providerId="LiveId" clId="{852B4C0F-FB6B-4FF3-8362-74B7577A66B1}" dt="2025-07-07T11:44:00.897" v="2701" actId="164"/>
+          <ac:picMkLst>
+            <pc:docMk/>
+            <pc:sldMk cId="0" sldId="256"/>
+            <ac:picMk id="14" creationId="{4CFA417F-B582-0A1F-C498-20D8AFD06BBB}"/>
+          </ac:picMkLst>
+        </pc:picChg>
+        <pc:picChg chg="add mod">
+          <ac:chgData name="Julien Sagnes" userId="949be203fa37cc39" providerId="LiveId" clId="{852B4C0F-FB6B-4FF3-8362-74B7577A66B1}" dt="2025-07-07T13:10:11.693" v="3167" actId="1076"/>
+          <ac:picMkLst>
+            <pc:docMk/>
+            <pc:sldMk cId="0" sldId="256"/>
+            <ac:picMk id="15" creationId="{4A7FCAFB-B34D-8278-25AA-AD29AED29D82}"/>
+          </ac:picMkLst>
+        </pc:picChg>
+        <pc:picChg chg="add del mod">
+          <ac:chgData name="Julien Sagnes" userId="949be203fa37cc39" providerId="LiveId" clId="{852B4C0F-FB6B-4FF3-8362-74B7577A66B1}" dt="2025-07-07T11:38:03.599" v="2513" actId="478"/>
+          <ac:picMkLst>
+            <pc:docMk/>
+            <pc:sldMk cId="0" sldId="256"/>
+            <ac:picMk id="16" creationId="{2D1FEA4C-B3D7-2F18-8B93-58CF9EB62A1D}"/>
+          </ac:picMkLst>
+        </pc:picChg>
+        <pc:picChg chg="add mod">
+          <ac:chgData name="Julien Sagnes" userId="949be203fa37cc39" providerId="LiveId" clId="{852B4C0F-FB6B-4FF3-8362-74B7577A66B1}" dt="2025-07-07T15:21:36.409" v="4831" actId="1076"/>
+          <ac:picMkLst>
+            <pc:docMk/>
+            <pc:sldMk cId="0" sldId="256"/>
+            <ac:picMk id="16" creationId="{C90CFCDC-A272-F16A-C5CB-A521D8DC8DA0}"/>
+          </ac:picMkLst>
+        </pc:picChg>
+        <pc:picChg chg="add mod">
+          <ac:chgData name="Julien Sagnes" userId="949be203fa37cc39" providerId="LiveId" clId="{852B4C0F-FB6B-4FF3-8362-74B7577A66B1}" dt="2025-07-07T13:10:13.813" v="3168" actId="1076"/>
+          <ac:picMkLst>
+            <pc:docMk/>
+            <pc:sldMk cId="0" sldId="256"/>
+            <ac:picMk id="19" creationId="{C006E4BB-D2D7-F069-023F-A56763476772}"/>
+          </ac:picMkLst>
+        </pc:picChg>
+        <pc:picChg chg="add mod">
+          <ac:chgData name="Julien Sagnes" userId="949be203fa37cc39" providerId="LiveId" clId="{852B4C0F-FB6B-4FF3-8362-74B7577A66B1}" dt="2025-07-07T14:17:54.255" v="4466" actId="1076"/>
+          <ac:picMkLst>
+            <pc:docMk/>
+            <pc:sldMk cId="0" sldId="256"/>
+            <ac:picMk id="25" creationId="{8720E50D-9863-1B1C-73F2-6DEA99F9B174}"/>
+          </ac:picMkLst>
+        </pc:picChg>
+        <pc:picChg chg="add mod modCrop">
+          <ac:chgData name="Julien Sagnes" userId="949be203fa37cc39" providerId="LiveId" clId="{852B4C0F-FB6B-4FF3-8362-74B7577A66B1}" dt="2025-07-07T14:18:02.899" v="4469" actId="1076"/>
+          <ac:picMkLst>
+            <pc:docMk/>
+            <pc:sldMk cId="0" sldId="256"/>
+            <ac:picMk id="27" creationId="{7AC5B4ED-21DD-FF3A-0DA8-C7E202FB1DF4}"/>
+          </ac:picMkLst>
+        </pc:picChg>
+        <pc:picChg chg="add del mod">
+          <ac:chgData name="Julien Sagnes" userId="949be203fa37cc39" providerId="LiveId" clId="{852B4C0F-FB6B-4FF3-8362-74B7577A66B1}" dt="2025-07-07T13:36:07.282" v="3516" actId="478"/>
+          <ac:picMkLst>
+            <pc:docMk/>
+            <pc:sldMk cId="0" sldId="256"/>
+            <ac:picMk id="29" creationId="{A83BFD4F-B1FB-91E0-4CCF-8CE69C1B735F}"/>
+          </ac:picMkLst>
+        </pc:picChg>
+        <pc:picChg chg="add mod">
+          <ac:chgData name="Julien Sagnes" userId="949be203fa37cc39" providerId="LiveId" clId="{852B4C0F-FB6B-4FF3-8362-74B7577A66B1}" dt="2025-07-07T14:44:06.841" v="4824" actId="1076"/>
+          <ac:picMkLst>
+            <pc:docMk/>
+            <pc:sldMk cId="0" sldId="256"/>
+            <ac:picMk id="34" creationId="{D2392334-9C70-F82D-A220-E87A656703A1}"/>
           </ac:picMkLst>
         </pc:picChg>
         <pc:extLst>
@@ -7426,7 +7626,7 @@
         </p:nvSpPr>
         <p:spPr bwMode="auto">
           <a:xfrm>
-            <a:off x="425961" y="3112457"/>
+            <a:off x="366619" y="3141130"/>
             <a:ext cx="14354525" cy="17833404"/>
           </a:xfrm>
           <a:prstGeom prst="rect">
@@ -7459,10 +7659,6 @@
         <p:txBody>
           <a:bodyPr wrap="none" anchor="t"/>
           <a:lstStyle/>
-          <a:p>
-            <a:pPr algn="l"/>
-            <a:endParaRPr lang="fr-FR" sz="2573" dirty="0"/>
-          </a:p>
           <a:p>
             <a:pPr algn="l"/>
             <a:endParaRPr lang="fr-FR" sz="2573" dirty="0"/>
@@ -7565,7 +7761,7 @@
           <a:lstStyle/>
           <a:p>
             <a:pPr algn="ctr"/>
-            <a:endParaRPr lang="fr-FR"/>
+            <a:endParaRPr lang="fr-FR" dirty="0"/>
           </a:p>
         </p:txBody>
       </p:sp>
@@ -7729,8 +7925,8 @@
         </p:nvSpPr>
         <p:spPr>
           <a:xfrm>
-            <a:off x="688775" y="3375321"/>
-            <a:ext cx="3555782" cy="646331"/>
+            <a:off x="619846" y="3375321"/>
+            <a:ext cx="3693640" cy="646331"/>
           </a:xfrm>
           <a:prstGeom prst="rect">
             <a:avLst/>
@@ -7750,6 +7946,9 @@
           <a:p>
             <a:r>
               <a:rPr lang="fr-FR" sz="3600" dirty="0">
+                <a:solidFill>
+                  <a:schemeClr val="tx2"/>
+                </a:solidFill>
                 <a:latin typeface="Berlin Sans FB" panose="020E0602020502020306" pitchFamily="34" charset="0"/>
               </a:rPr>
               <a:t>Objectif du projet</a:t>
@@ -7772,7 +7971,7 @@
         <p:spPr>
           <a:xfrm>
             <a:off x="688775" y="4139676"/>
-            <a:ext cx="6201642" cy="4893647"/>
+            <a:ext cx="7063440" cy="2246769"/>
           </a:xfrm>
           <a:prstGeom prst="rect">
             <a:avLst/>
@@ -7785,78 +7984,73 @@
           </a:bodyPr>
           <a:lstStyle/>
           <a:p>
-            <a:pPr algn="just"/>
-            <a:r>
-              <a:rPr lang="fr-FR" sz="2400" dirty="0">
+            <a:pPr algn="l"/>
+            <a:r>
+              <a:rPr lang="fr-FR" sz="2000" dirty="0">
                 <a:latin typeface="Grandview" panose="020B0502040204020203" pitchFamily="34" charset="0"/>
               </a:rPr>
-              <a:t>Simulation et réalisation d’une </a:t>
-            </a:r>
-            <a:r>
-              <a:rPr lang="fr-FR" sz="2400" b="1" dirty="0">
+              <a:t>Simulation et fabrication d’une </a:t>
+            </a:r>
+            <a:r>
+              <a:rPr lang="fr-FR" sz="2000" b="1" dirty="0">
                 <a:latin typeface="Grandview" panose="020B0502040204020203" pitchFamily="34" charset="0"/>
               </a:rPr>
-              <a:t>pince robotique à trois doigts souples</a:t>
-            </a:r>
-            <a:r>
-              <a:rPr lang="fr-FR" sz="2400" dirty="0">
+              <a:t>pince à trois doigts souples en TPU</a:t>
+            </a:r>
+            <a:r>
+              <a:rPr lang="fr-FR" sz="2000" dirty="0">
                 <a:latin typeface="Grandview" panose="020B0502040204020203" pitchFamily="34" charset="0"/>
               </a:rPr>
-              <a:t>, conçue pour saisir des objets tels que des fruits et des légumes, avec une capacité maximale de 5 kg. Inspiré du robot </a:t>
-            </a:r>
-            <a:r>
-              <a:rPr lang="fr-FR" sz="2400" b="1" dirty="0" err="1">
+              <a:t>, destinée à la préhension d’objets comme des fruits et des légumes. Les doigts, dont la géométrie s’inspire de la </a:t>
+            </a:r>
+            <a:r>
+              <a:rPr lang="fr-FR" sz="2000" b="1" dirty="0">
                 <a:latin typeface="Grandview" panose="020B0502040204020203" pitchFamily="34" charset="0"/>
               </a:rPr>
-              <a:t>SpiRob</a:t>
-            </a:r>
-            <a:r>
-              <a:rPr lang="fr-FR" sz="2400" dirty="0">
+              <a:t>spirale logarithmique</a:t>
+            </a:r>
+            <a:r>
+              <a:rPr lang="fr-FR" sz="2000" dirty="0">
                 <a:latin typeface="Grandview" panose="020B0502040204020203" pitchFamily="34" charset="0"/>
               </a:rPr>
-              <a:t> et des structures souples bio-inspirées, le dispositif intègre des doigts imprimés en 3D</a:t>
-            </a:r>
-            <a:r>
-              <a:rPr lang="fr-FR" sz="2400" b="1" dirty="0">
+              <a:t>, sont actionnés par des </a:t>
+            </a:r>
+            <a:r>
+              <a:rPr lang="fr-FR" sz="2000" b="1" dirty="0">
                 <a:latin typeface="Grandview" panose="020B0502040204020203" pitchFamily="34" charset="0"/>
               </a:rPr>
-              <a:t>, </a:t>
-            </a:r>
-            <a:r>
-              <a:rPr lang="fr-FR" sz="2400" dirty="0">
+              <a:t>câbles via un système vis-écrou</a:t>
+            </a:r>
+            <a:r>
+              <a:rPr lang="fr-FR" sz="2000" dirty="0">
                 <a:latin typeface="Grandview" panose="020B0502040204020203" pitchFamily="34" charset="0"/>
               </a:rPr>
-              <a:t>disposés symétriquement autour d’un axe central et actionnés par des câbles mis en tension via un mécanisme vis-écrou. La souplesse des doigts en </a:t>
-            </a:r>
-            <a:r>
-              <a:rPr lang="fr-FR" sz="2400" b="1" dirty="0">
+              <a:t>. Leur </a:t>
+            </a:r>
+            <a:r>
+              <a:rPr lang="fr-FR" sz="2000" b="1" dirty="0">
                 <a:latin typeface="Grandview" panose="020B0502040204020203" pitchFamily="34" charset="0"/>
               </a:rPr>
-              <a:t>TPU</a:t>
-            </a:r>
-            <a:r>
-              <a:rPr lang="fr-FR" sz="2400" dirty="0">
+              <a:t>flexibilité</a:t>
+            </a:r>
+            <a:r>
+              <a:rPr lang="fr-FR" sz="2000" dirty="0">
                 <a:latin typeface="Grandview" panose="020B0502040204020203" pitchFamily="34" charset="0"/>
               </a:rPr>
-              <a:t> leur permet de </a:t>
-            </a:r>
-            <a:r>
-              <a:rPr lang="fr-FR" sz="2400" b="1" dirty="0">
+              <a:t> assure le retour en position droite après le relâchement des câbles, d’où la nécessité d’</a:t>
+            </a:r>
+            <a:r>
+              <a:rPr lang="fr-FR" sz="2000" b="1" dirty="0">
                 <a:latin typeface="Grandview" panose="020B0502040204020203" pitchFamily="34" charset="0"/>
               </a:rPr>
-              <a:t>revenir naturellement à leur position initiale </a:t>
-            </a:r>
-            <a:r>
-              <a:rPr lang="fr-FR" sz="2400" dirty="0">
+              <a:t>éviter toute plastification </a:t>
+            </a:r>
+            <a:r>
+              <a:rPr lang="fr-FR" sz="2000" dirty="0">
                 <a:latin typeface="Grandview" panose="020B0502040204020203" pitchFamily="34" charset="0"/>
               </a:rPr>
-              <a:t>après la déformation.</a:t>
-            </a:r>
-            <a:endParaRPr lang="fr-FR" sz="2400" dirty="0">
-              <a:latin typeface="Grandview" panose="020B0502040204020203" pitchFamily="34" charset="0"/>
-              <a:ea typeface="Roboto Condensed" panose="02000000000000000000" pitchFamily="2" charset="0"/>
-              <a:cs typeface="Helvetica" panose="020B0604020202020204" pitchFamily="34" charset="0"/>
-            </a:endParaRPr>
+              <a:t>du matériau.</a:t>
+            </a:r>
           </a:p>
         </p:txBody>
       </p:sp>
@@ -7874,8 +8068,8 @@
         </p:nvSpPr>
         <p:spPr>
           <a:xfrm>
-            <a:off x="444855" y="3049785"/>
-            <a:ext cx="7510864" cy="6696571"/>
+            <a:off x="386995" y="3154545"/>
+            <a:ext cx="7527210" cy="9026764"/>
           </a:xfrm>
           <a:custGeom>
             <a:avLst/>
@@ -7959,7 +8153,7 @@
         </p:nvSpPr>
         <p:spPr>
           <a:xfrm>
-            <a:off x="688775" y="9853256"/>
+            <a:off x="688775" y="12194545"/>
             <a:ext cx="2023311" cy="646331"/>
           </a:xfrm>
           <a:prstGeom prst="rect">
@@ -7980,6 +8174,9 @@
           <a:p>
             <a:r>
               <a:rPr lang="fr-FR" sz="3600" dirty="0">
+                <a:solidFill>
+                  <a:schemeClr val="tx2"/>
+                </a:solidFill>
                 <a:latin typeface="Berlin Sans FB" panose="020E0602020502020306" pitchFamily="34" charset="0"/>
               </a:rPr>
               <a:t>Méthodes</a:t>
@@ -8001,8 +8198,8 @@
         </p:nvSpPr>
         <p:spPr>
           <a:xfrm>
-            <a:off x="688775" y="10606486"/>
-            <a:ext cx="6491832" cy="6370975"/>
+            <a:off x="692419" y="13053052"/>
+            <a:ext cx="6491832" cy="4093428"/>
           </a:xfrm>
           <a:prstGeom prst="rect">
             <a:avLst/>
@@ -8020,16 +8217,70 @@
               <a:buChar char="•"/>
             </a:pPr>
             <a:r>
-              <a:rPr lang="fr-FR" sz="2400" b="1" dirty="0">
+              <a:rPr lang="fr-FR" sz="2000" dirty="0">
                 <a:latin typeface="Grandview" panose="020B0502040204020203" pitchFamily="34" charset="0"/>
               </a:rPr>
-              <a:t>Recherche </a:t>
-            </a:r>
-            <a:r>
-              <a:rPr lang="fr-FR" sz="2400" dirty="0">
+              <a:t>Modélisation et conception des pièces sur </a:t>
+            </a:r>
+            <a:r>
+              <a:rPr lang="fr-FR" sz="2000" b="1" dirty="0">
                 <a:latin typeface="Grandview" panose="020B0502040204020203" pitchFamily="34" charset="0"/>
               </a:rPr>
-              <a:t>de solutions existantes et fonctionnelles pour assurer la tension des câbles et leur contrôle, permettant d’assurer un actionnement robuste de la pince</a:t>
+              <a:t>SolidWorks</a:t>
+            </a:r>
+            <a:r>
+              <a:rPr lang="fr-FR" sz="2000" dirty="0">
+                <a:latin typeface="Grandview" panose="020B0502040204020203" pitchFamily="34" charset="0"/>
+              </a:rPr>
+              <a:t>, en prenant en compte les aspects de conception tels que les </a:t>
+            </a:r>
+            <a:r>
+              <a:rPr lang="fr-FR" sz="2000" b="1" dirty="0">
+                <a:latin typeface="Grandview" panose="020B0502040204020203" pitchFamily="34" charset="0"/>
+              </a:rPr>
+              <a:t>jeux</a:t>
+            </a:r>
+            <a:r>
+              <a:rPr lang="fr-FR" sz="2000" dirty="0">
+                <a:latin typeface="Grandview" panose="020B0502040204020203" pitchFamily="34" charset="0"/>
+              </a:rPr>
+              <a:t>, les </a:t>
+            </a:r>
+            <a:r>
+              <a:rPr lang="fr-FR" sz="2000" b="1" dirty="0">
+                <a:latin typeface="Grandview" panose="020B0502040204020203" pitchFamily="34" charset="0"/>
+              </a:rPr>
+              <a:t>frottements</a:t>
+            </a:r>
+            <a:r>
+              <a:rPr lang="fr-FR" sz="2000" dirty="0">
+                <a:latin typeface="Grandview" panose="020B0502040204020203" pitchFamily="34" charset="0"/>
+              </a:rPr>
+              <a:t>, l’</a:t>
+            </a:r>
+            <a:r>
+              <a:rPr lang="fr-FR" sz="2000" b="1" dirty="0">
+                <a:latin typeface="Grandview" panose="020B0502040204020203" pitchFamily="34" charset="0"/>
+              </a:rPr>
+              <a:t>hyperstatisme</a:t>
+            </a:r>
+            <a:r>
+              <a:rPr lang="fr-FR" sz="2000" dirty="0">
+                <a:latin typeface="Grandview" panose="020B0502040204020203" pitchFamily="34" charset="0"/>
+              </a:rPr>
+              <a:t> ainsi que la </a:t>
+            </a:r>
+            <a:r>
+              <a:rPr lang="fr-FR" sz="2000" b="1" dirty="0">
+                <a:latin typeface="Grandview" panose="020B0502040204020203" pitchFamily="34" charset="0"/>
+              </a:rPr>
+              <a:t>transmission du couple </a:t>
+            </a:r>
+            <a:r>
+              <a:rPr lang="fr-FR" sz="2000" dirty="0">
+                <a:latin typeface="Grandview" panose="020B0502040204020203" pitchFamily="34" charset="0"/>
+              </a:rPr>
+              <a:t>moteur vers la vis.</a:t>
             </a:r>
           </a:p>
           <a:p>
@@ -8038,22 +8289,34 @@
               <a:buChar char="•"/>
             </a:pPr>
             <a:r>
-              <a:rPr lang="fr-FR" sz="2400" dirty="0">
+              <a:rPr lang="fr-FR" sz="2000" dirty="0">
                 <a:latin typeface="Grandview" panose="020B0502040204020203" pitchFamily="34" charset="0"/>
               </a:rPr>
-              <a:t>Modélisation et conception des pièces sur </a:t>
-            </a:r>
-            <a:r>
-              <a:rPr lang="fr-FR" sz="2400" b="1" dirty="0">
+              <a:t>Simulation par éléments finis de la pince sous </a:t>
+            </a:r>
+            <a:r>
+              <a:rPr lang="fr-FR" sz="2000" b="1" dirty="0">
                 <a:latin typeface="Grandview" panose="020B0502040204020203" pitchFamily="34" charset="0"/>
               </a:rPr>
-              <a:t>SolidWorks</a:t>
-            </a:r>
-            <a:r>
-              <a:rPr lang="fr-FR" sz="2400" dirty="0">
+              <a:t>SolidWorks Simulation</a:t>
+            </a:r>
+            <a:r>
+              <a:rPr lang="fr-FR" sz="2000" dirty="0">
                 <a:latin typeface="Grandview" panose="020B0502040204020203" pitchFamily="34" charset="0"/>
               </a:rPr>
-              <a:t>, en prenant en compte les aspects de conception tels que les jeux fonctionnels, les frottements, l’hyperstatisme ainsi que la transmission du couple moteur vers la vis.</a:t>
+              <a:t>, avec une analyse de l’élasticité à partir des </a:t>
+            </a:r>
+            <a:r>
+              <a:rPr lang="fr-FR" sz="2000" b="1" dirty="0">
+                <a:latin typeface="Grandview" panose="020B0502040204020203" pitchFamily="34" charset="0"/>
+              </a:rPr>
+              <a:t>contraintes équivalentes de Von Mises</a:t>
+            </a:r>
+            <a:r>
+              <a:rPr lang="fr-FR" sz="2000" dirty="0">
+                <a:latin typeface="Grandview" panose="020B0502040204020203" pitchFamily="34" charset="0"/>
+              </a:rPr>
+              <a:t>, afin de vérifier que le matériau reste dans le domaine élastique et n’entre pas en plasticité.</a:t>
             </a:r>
           </a:p>
           <a:p>
@@ -8062,34 +8325,34 @@
               <a:buChar char="•"/>
             </a:pPr>
             <a:r>
-              <a:rPr lang="fr-FR" sz="2400" dirty="0">
+              <a:rPr lang="fr-FR" sz="2000" dirty="0">
                 <a:latin typeface="Grandview" panose="020B0502040204020203" pitchFamily="34" charset="0"/>
               </a:rPr>
-              <a:t>Simulation de la pince sous </a:t>
-            </a:r>
-            <a:r>
-              <a:rPr lang="fr-FR" sz="2400" b="1" dirty="0">
+              <a:t>Réalisation de la pince en combinant des pièces </a:t>
+            </a:r>
+            <a:r>
+              <a:rPr lang="fr-FR" sz="2000" b="1" dirty="0">
                 <a:latin typeface="Grandview" panose="020B0502040204020203" pitchFamily="34" charset="0"/>
               </a:rPr>
-              <a:t>SolidWorks Simulation</a:t>
-            </a:r>
-            <a:r>
-              <a:rPr lang="fr-FR" sz="2400" dirty="0">
+              <a:t>MAKERBEAM</a:t>
+            </a:r>
+            <a:r>
+              <a:rPr lang="fr-FR" sz="2000" dirty="0">
                 <a:latin typeface="Grandview" panose="020B0502040204020203" pitchFamily="34" charset="0"/>
               </a:rPr>
-              <a:t>, avec une analyse de l’élasticité à partir des </a:t>
-            </a:r>
-            <a:r>
-              <a:rPr lang="fr-FR" sz="2400" b="1" dirty="0">
+              <a:t> et des éléments </a:t>
+            </a:r>
+            <a:r>
+              <a:rPr lang="fr-FR" sz="2000" b="1" dirty="0">
                 <a:latin typeface="Grandview" panose="020B0502040204020203" pitchFamily="34" charset="0"/>
               </a:rPr>
-              <a:t>contraintes équivalentes de Von Mises</a:t>
-            </a:r>
-            <a:r>
-              <a:rPr lang="fr-FR" sz="2400" dirty="0">
+              <a:t>imprimés en 3D</a:t>
+            </a:r>
+            <a:r>
+              <a:rPr lang="fr-FR" sz="2000" dirty="0">
                 <a:latin typeface="Grandview" panose="020B0502040204020203" pitchFamily="34" charset="0"/>
               </a:rPr>
-              <a:t>, afin de vérifier que le matériau reste dans le domaine élastique et n’entre pas en plasticité.</a:t>
+              <a:t>.</a:t>
             </a:r>
           </a:p>
         </p:txBody>
@@ -8108,8 +8371,8 @@
         </p:nvSpPr>
         <p:spPr>
           <a:xfrm>
-            <a:off x="425961" y="7854462"/>
-            <a:ext cx="7510864" cy="10314032"/>
+            <a:off x="366619" y="10953875"/>
+            <a:ext cx="6995259" cy="6784791"/>
           </a:xfrm>
           <a:custGeom>
             <a:avLst/>
@@ -8214,6 +8477,9 @@
           <a:p>
             <a:r>
               <a:rPr lang="fr-FR" sz="3600" dirty="0">
+                <a:solidFill>
+                  <a:schemeClr val="tx2"/>
+                </a:solidFill>
                 <a:latin typeface="Berlin Sans FB" panose="020E0602020502020306" pitchFamily="34" charset="0"/>
               </a:rPr>
               <a:t>Résultats</a:t>
@@ -8235,7 +8501,7 @@
         </p:nvSpPr>
         <p:spPr>
           <a:xfrm>
-            <a:off x="688775" y="18198376"/>
+            <a:off x="688775" y="17699071"/>
             <a:ext cx="2194832" cy="646331"/>
           </a:xfrm>
           <a:prstGeom prst="rect">
@@ -8256,6 +8522,9 @@
           <a:p>
             <a:r>
               <a:rPr lang="fr-FR" sz="3600" dirty="0">
+                <a:solidFill>
+                  <a:schemeClr val="tx2"/>
+                </a:solidFill>
                 <a:latin typeface="Berlin Sans FB" panose="020E0602020502020306" pitchFamily="34" charset="0"/>
               </a:rPr>
               <a:t>Conclusion</a:t>
@@ -8263,6 +8532,1180 @@
           </a:p>
         </p:txBody>
       </p:sp>
+      <p:grpSp>
+        <p:nvGrpSpPr>
+          <p:cNvPr id="18" name="Groupe 17">
+            <a:extLst>
+              <a:ext uri="{FF2B5EF4-FFF2-40B4-BE49-F238E27FC236}">
+                <a16:creationId xmlns:a16="http://schemas.microsoft.com/office/drawing/2014/main" id="{348806F0-6F60-247F-7A79-EB89F1B6FC0D}"/>
+              </a:ext>
+            </a:extLst>
+          </p:cNvPr>
+          <p:cNvGrpSpPr/>
+          <p:nvPr/>
+        </p:nvGrpSpPr>
+        <p:grpSpPr>
+          <a:xfrm>
+            <a:off x="1171505" y="6318992"/>
+            <a:ext cx="5920118" cy="2641479"/>
+            <a:chOff x="1653800" y="7148919"/>
+            <a:chExt cx="4556380" cy="2021760"/>
+          </a:xfrm>
+        </p:grpSpPr>
+        <p:pic>
+          <p:nvPicPr>
+            <p:cNvPr id="14" name="Image 13" descr="Une image contenant texte, diagramme, cercle, capture d’écran&#10;&#10;Le contenu généré par l’IA peut être incorrect.">
+              <a:extLst>
+                <a:ext uri="{FF2B5EF4-FFF2-40B4-BE49-F238E27FC236}">
+                  <a16:creationId xmlns:a16="http://schemas.microsoft.com/office/drawing/2014/main" id="{4CFA417F-B582-0A1F-C498-20D8AFD06BBB}"/>
+                </a:ext>
+              </a:extLst>
+            </p:cNvPr>
+            <p:cNvPicPr>
+              <a:picLocks noChangeAspect="1"/>
+            </p:cNvPicPr>
+            <p:nvPr/>
+          </p:nvPicPr>
+          <p:blipFill>
+            <a:blip r:embed="rId6">
+              <a:extLst>
+                <a:ext uri="{28A0092B-C50C-407E-A947-70E740481C1C}">
+                  <a14:useLocalDpi xmlns:a14="http://schemas.microsoft.com/office/drawing/2010/main" val="0"/>
+                </a:ext>
+              </a:extLst>
+            </a:blip>
+            <a:stretch>
+              <a:fillRect/>
+            </a:stretch>
+          </p:blipFill>
+          <p:spPr>
+            <a:xfrm>
+              <a:off x="1653800" y="7148919"/>
+              <a:ext cx="4556380" cy="2021760"/>
+            </a:xfrm>
+            <a:prstGeom prst="rect">
+              <a:avLst/>
+            </a:prstGeom>
+          </p:spPr>
+        </p:pic>
+        <p:sp>
+          <p:nvSpPr>
+            <p:cNvPr id="17" name="Rectangle 16">
+              <a:extLst>
+                <a:ext uri="{FF2B5EF4-FFF2-40B4-BE49-F238E27FC236}">
+                  <a16:creationId xmlns:a16="http://schemas.microsoft.com/office/drawing/2014/main" id="{54216D39-8C29-866D-D82F-374F32776D62}"/>
+                </a:ext>
+              </a:extLst>
+            </p:cNvPr>
+            <p:cNvSpPr/>
+            <p:nvPr/>
+          </p:nvSpPr>
+          <p:spPr>
+            <a:xfrm>
+              <a:off x="3707247" y="7148919"/>
+              <a:ext cx="2502933" cy="483124"/>
+            </a:xfrm>
+            <a:prstGeom prst="rect">
+              <a:avLst/>
+            </a:prstGeom>
+            <a:solidFill>
+              <a:schemeClr val="bg1"/>
+            </a:solidFill>
+            <a:ln>
+              <a:solidFill>
+                <a:schemeClr val="bg1"/>
+              </a:solidFill>
+            </a:ln>
+          </p:spPr>
+          <p:style>
+            <a:lnRef idx="2">
+              <a:schemeClr val="accent6"/>
+            </a:lnRef>
+            <a:fillRef idx="1">
+              <a:schemeClr val="lt1"/>
+            </a:fillRef>
+            <a:effectRef idx="0">
+              <a:schemeClr val="accent6"/>
+            </a:effectRef>
+            <a:fontRef idx="minor">
+              <a:schemeClr val="dk1"/>
+            </a:fontRef>
+          </p:style>
+          <p:txBody>
+            <a:bodyPr rtlCol="0" anchor="ctr"/>
+            <a:lstStyle/>
+            <a:p>
+              <a:pPr algn="ctr"/>
+              <a:endParaRPr lang="fr-FR"/>
+            </a:p>
+          </p:txBody>
+        </p:sp>
+      </p:grpSp>
+      <mc:AlternateContent xmlns:mc="http://schemas.openxmlformats.org/markup-compatibility/2006" xmlns:a14="http://schemas.microsoft.com/office/drawing/2010/main">
+        <mc:Choice Requires="a14">
+          <p:sp>
+            <p:nvSpPr>
+              <p:cNvPr id="2" name="ZoneTexte 1">
+                <a:extLst>
+                  <a:ext uri="{FF2B5EF4-FFF2-40B4-BE49-F238E27FC236}">
+                    <a16:creationId xmlns:a16="http://schemas.microsoft.com/office/drawing/2014/main" id="{4C9C7473-640D-E58C-360B-62ED61A225AD}"/>
+                  </a:ext>
+                </a:extLst>
+              </p:cNvPr>
+              <p:cNvSpPr txBox="1"/>
+              <p:nvPr/>
+            </p:nvSpPr>
+            <p:spPr>
+              <a:xfrm>
+                <a:off x="8022153" y="4107979"/>
+                <a:ext cx="6710201" cy="1938992"/>
+              </a:xfrm>
+              <a:prstGeom prst="rect">
+                <a:avLst/>
+              </a:prstGeom>
+              <a:noFill/>
+            </p:spPr>
+            <p:txBody>
+              <a:bodyPr wrap="square" rtlCol="0">
+                <a:spAutoFit/>
+              </a:bodyPr>
+              <a:lstStyle/>
+              <a:p>
+                <a:pPr algn="l"/>
+                <a:r>
+                  <a:rPr lang="fr-FR" sz="2000" dirty="0">
+                    <a:latin typeface="Grandview" panose="020B0502040204020203" pitchFamily="34" charset="0"/>
+                  </a:rPr>
+                  <a:t>Matériau pour les doigts : </a:t>
+                </a:r>
+                <a:r>
+                  <a:rPr lang="fr-FR" sz="2000" b="1" dirty="0">
+                    <a:latin typeface="Grandview" panose="020B0502040204020203" pitchFamily="34" charset="0"/>
+                  </a:rPr>
+                  <a:t>eTPU-95a</a:t>
+                </a:r>
+              </a:p>
+              <a:p>
+                <a:pPr marL="342900" indent="-342900" algn="l">
+                  <a:buFont typeface="Arial" panose="020B0604020202020204" pitchFamily="34" charset="0"/>
+                  <a:buChar char="•"/>
+                </a:pPr>
+                <a:r>
+                  <a:rPr lang="fr-FR" sz="2000" dirty="0">
+                    <a:latin typeface="Grandview" panose="020B0502040204020203" pitchFamily="34" charset="0"/>
+                  </a:rPr>
+                  <a:t>Module d’Young : 30 MPa, et </a:t>
+                </a:r>
+                <a14:m>
+                  <m:oMath xmlns:m="http://schemas.openxmlformats.org/officeDocument/2006/math">
+                    <m:sSub>
+                      <m:sSubPr>
+                        <m:ctrlPr>
+                          <a:rPr lang="fr-FR" sz="2000" b="0" i="1" smtClean="0">
+                            <a:latin typeface="Cambria Math" panose="02040503050406030204" pitchFamily="18" charset="0"/>
+                          </a:rPr>
+                        </m:ctrlPr>
+                      </m:sSubPr>
+                      <m:e>
+                        <m:r>
+                          <a:rPr lang="fr-FR" sz="2000" b="0" i="1" smtClean="0">
+                            <a:latin typeface="Cambria Math" panose="02040503050406030204" pitchFamily="18" charset="0"/>
+                          </a:rPr>
+                          <m:t>𝜎</m:t>
+                        </m:r>
+                      </m:e>
+                      <m:sub>
+                        <m:r>
+                          <a:rPr lang="fr-FR" sz="2000" b="0" i="1" smtClean="0">
+                            <a:latin typeface="Cambria Math" panose="02040503050406030204" pitchFamily="18" charset="0"/>
+                          </a:rPr>
+                          <m:t>𝑚𝑎𝑥</m:t>
+                        </m:r>
+                      </m:sub>
+                    </m:sSub>
+                  </m:oMath>
+                </a14:m>
+                <a:r>
+                  <a:rPr lang="fr-FR" sz="2000" dirty="0">
+                    <a:latin typeface="Grandview" panose="020B0502040204020203" pitchFamily="34" charset="0"/>
+                  </a:rPr>
+                  <a:t> = 8,6 MPa</a:t>
+                </a:r>
+              </a:p>
+              <a:p>
+                <a:pPr algn="l"/>
+                <a:r>
+                  <a:rPr lang="fr-FR" sz="2000" dirty="0">
+                    <a:latin typeface="Grandview" panose="020B0502040204020203" pitchFamily="34" charset="0"/>
+                  </a:rPr>
+                  <a:t>Matériau pour les autres pièces : </a:t>
+                </a:r>
+                <a:r>
+                  <a:rPr lang="fr-FR" sz="2000" b="1" dirty="0">
+                    <a:latin typeface="Grandview" panose="020B0502040204020203" pitchFamily="34" charset="0"/>
+                  </a:rPr>
+                  <a:t>PLA</a:t>
+                </a:r>
+              </a:p>
+              <a:p>
+                <a:pPr marL="342900" indent="-342900" algn="l">
+                  <a:buFont typeface="Arial" panose="020B0604020202020204" pitchFamily="34" charset="0"/>
+                  <a:buChar char="•"/>
+                </a:pPr>
+                <a:r>
+                  <a:rPr lang="fr-FR" sz="2000" dirty="0">
+                    <a:latin typeface="Grandview" panose="020B0502040204020203" pitchFamily="34" charset="0"/>
+                  </a:rPr>
+                  <a:t>Module d’Young : 30000 MPa</a:t>
+                </a:r>
+              </a:p>
+              <a:p>
+                <a:pPr algn="l"/>
+                <a:r>
+                  <a:rPr lang="fr-FR" sz="2000" dirty="0">
+                    <a:latin typeface="Grandview" panose="020B0502040204020203" pitchFamily="34" charset="0"/>
+                  </a:rPr>
+                  <a:t>Grâce à sa rigidité supérieure, le </a:t>
+                </a:r>
+                <a:r>
+                  <a:rPr lang="fr-FR" sz="2000" b="1" dirty="0">
+                    <a:latin typeface="Grandview" panose="020B0502040204020203" pitchFamily="34" charset="0"/>
+                  </a:rPr>
+                  <a:t>PLA</a:t>
+                </a:r>
+                <a:r>
+                  <a:rPr lang="fr-FR" sz="2000" dirty="0">
+                    <a:latin typeface="Grandview" panose="020B0502040204020203" pitchFamily="34" charset="0"/>
+                  </a:rPr>
+                  <a:t> garantit que les déformations se produisent uniquement dans les doigts.</a:t>
+                </a:r>
+              </a:p>
+            </p:txBody>
+          </p:sp>
+        </mc:Choice>
+        <mc:Fallback xmlns="">
+          <p:sp>
+            <p:nvSpPr>
+              <p:cNvPr id="2" name="ZoneTexte 1">
+                <a:extLst>
+                  <a:ext uri="{FF2B5EF4-FFF2-40B4-BE49-F238E27FC236}">
+                    <a16:creationId xmlns:a16="http://schemas.microsoft.com/office/drawing/2014/main" id="{4C9C7473-640D-E58C-360B-62ED61A225AD}"/>
+                  </a:ext>
+                </a:extLst>
+              </p:cNvPr>
+              <p:cNvSpPr txBox="1">
+                <a:spLocks noRot="1" noChangeAspect="1" noMove="1" noResize="1" noEditPoints="1" noAdjustHandles="1" noChangeArrowheads="1" noChangeShapeType="1" noTextEdit="1"/>
+              </p:cNvSpPr>
+              <p:nvPr/>
+            </p:nvSpPr>
+            <p:spPr>
+              <a:xfrm>
+                <a:off x="8022153" y="4107979"/>
+                <a:ext cx="6710201" cy="1938992"/>
+              </a:xfrm>
+              <a:prstGeom prst="rect">
+                <a:avLst/>
+              </a:prstGeom>
+              <a:blipFill>
+                <a:blip r:embed="rId8"/>
+                <a:stretch>
+                  <a:fillRect l="-999" t="-1887" b="-4717"/>
+                </a:stretch>
+              </a:blipFill>
+            </p:spPr>
+            <p:txBody>
+              <a:bodyPr/>
+              <a:lstStyle/>
+              <a:p>
+                <a:r>
+                  <a:rPr lang="fr-FR">
+                    <a:noFill/>
+                  </a:rPr>
+                  <a:t> </a:t>
+                </a:r>
+              </a:p>
+            </p:txBody>
+          </p:sp>
+        </mc:Fallback>
+      </mc:AlternateContent>
+      <p:pic>
+        <p:nvPicPr>
+          <p:cNvPr id="15" name="Image 14">
+            <a:extLst>
+              <a:ext uri="{FF2B5EF4-FFF2-40B4-BE49-F238E27FC236}">
+                <a16:creationId xmlns:a16="http://schemas.microsoft.com/office/drawing/2014/main" id="{4A7FCAFB-B34D-8278-25AA-AD29AED29D82}"/>
+              </a:ext>
+            </a:extLst>
+          </p:cNvPr>
+          <p:cNvPicPr>
+            <a:picLocks noChangeAspect="1"/>
+          </p:cNvPicPr>
+          <p:nvPr/>
+        </p:nvPicPr>
+        <p:blipFill>
+          <a:blip r:embed="rId9">
+            <a:extLst>
+              <a:ext uri="{28A0092B-C50C-407E-A947-70E740481C1C}">
+                <a14:useLocalDpi xmlns:a14="http://schemas.microsoft.com/office/drawing/2010/main" val="0"/>
+              </a:ext>
+            </a:extLst>
+          </a:blip>
+          <a:stretch>
+            <a:fillRect/>
+          </a:stretch>
+        </p:blipFill>
+        <p:spPr>
+          <a:xfrm>
+            <a:off x="11673845" y="6568215"/>
+            <a:ext cx="2766303" cy="2830743"/>
+          </a:xfrm>
+          <a:prstGeom prst="rect">
+            <a:avLst/>
+          </a:prstGeom>
+        </p:spPr>
+      </p:pic>
+      <p:pic>
+        <p:nvPicPr>
+          <p:cNvPr id="19" name="Image 18" descr="Une image contenant capture d’écran&#10;&#10;Le contenu généré par l’IA peut être incorrect.">
+            <a:extLst>
+              <a:ext uri="{FF2B5EF4-FFF2-40B4-BE49-F238E27FC236}">
+                <a16:creationId xmlns:a16="http://schemas.microsoft.com/office/drawing/2014/main" id="{C006E4BB-D2D7-F069-023F-A56763476772}"/>
+              </a:ext>
+            </a:extLst>
+          </p:cNvPr>
+          <p:cNvPicPr>
+            <a:picLocks noChangeAspect="1"/>
+          </p:cNvPicPr>
+          <p:nvPr/>
+        </p:nvPicPr>
+        <p:blipFill>
+          <a:blip r:embed="rId10">
+            <a:extLst>
+              <a:ext uri="{28A0092B-C50C-407E-A947-70E740481C1C}">
+                <a14:useLocalDpi xmlns:a14="http://schemas.microsoft.com/office/drawing/2010/main" val="0"/>
+              </a:ext>
+            </a:extLst>
+          </a:blip>
+          <a:stretch>
+            <a:fillRect/>
+          </a:stretch>
+        </p:blipFill>
+        <p:spPr>
+          <a:xfrm>
+            <a:off x="8155551" y="6568215"/>
+            <a:ext cx="3295934" cy="2830743"/>
+          </a:xfrm>
+          <a:prstGeom prst="rect">
+            <a:avLst/>
+          </a:prstGeom>
+        </p:spPr>
+      </p:pic>
+      <p:sp>
+        <p:nvSpPr>
+          <p:cNvPr id="22" name="ZoneTexte 21">
+            <a:extLst>
+              <a:ext uri="{FF2B5EF4-FFF2-40B4-BE49-F238E27FC236}">
+                <a16:creationId xmlns:a16="http://schemas.microsoft.com/office/drawing/2014/main" id="{79955613-CD37-F288-8B6B-803F909EF8C3}"/>
+              </a:ext>
+            </a:extLst>
+          </p:cNvPr>
+          <p:cNvSpPr txBox="1"/>
+          <p:nvPr/>
+        </p:nvSpPr>
+        <p:spPr>
+          <a:xfrm>
+            <a:off x="8716607" y="6155879"/>
+            <a:ext cx="184730" cy="400110"/>
+          </a:xfrm>
+          <a:prstGeom prst="rect">
+            <a:avLst/>
+          </a:prstGeom>
+          <a:noFill/>
+        </p:spPr>
+        <p:txBody>
+          <a:bodyPr wrap="none" rtlCol="0">
+            <a:spAutoFit/>
+          </a:bodyPr>
+          <a:lstStyle/>
+          <a:p>
+            <a:endParaRPr lang="fr-FR" sz="2000" dirty="0">
+              <a:latin typeface="Grandview" panose="020B0502040204020203" pitchFamily="34" charset="0"/>
+            </a:endParaRPr>
+          </a:p>
+        </p:txBody>
+      </p:sp>
+      <p:sp>
+        <p:nvSpPr>
+          <p:cNvPr id="23" name="ZoneTexte 22">
+            <a:extLst>
+              <a:ext uri="{FF2B5EF4-FFF2-40B4-BE49-F238E27FC236}">
+                <a16:creationId xmlns:a16="http://schemas.microsoft.com/office/drawing/2014/main" id="{BFFE58B0-2AE4-1EB6-82C0-94306E5923C3}"/>
+              </a:ext>
+            </a:extLst>
+          </p:cNvPr>
+          <p:cNvSpPr txBox="1"/>
+          <p:nvPr/>
+        </p:nvSpPr>
+        <p:spPr>
+          <a:xfrm>
+            <a:off x="8155551" y="6131484"/>
+            <a:ext cx="3693640" cy="400110"/>
+          </a:xfrm>
+          <a:prstGeom prst="rect">
+            <a:avLst/>
+          </a:prstGeom>
+          <a:noFill/>
+        </p:spPr>
+        <p:txBody>
+          <a:bodyPr wrap="none" rtlCol="0">
+            <a:spAutoFit/>
+          </a:bodyPr>
+          <a:lstStyle/>
+          <a:p>
+            <a:r>
+              <a:rPr lang="fr-FR" sz="2000" b="1" dirty="0">
+                <a:latin typeface="Grandview" panose="020B0502040204020203" pitchFamily="34" charset="0"/>
+              </a:rPr>
+              <a:t>Simulation par éléments finis :</a:t>
+            </a:r>
+          </a:p>
+        </p:txBody>
+      </p:sp>
+      <p:pic>
+        <p:nvPicPr>
+          <p:cNvPr id="25" name="Image 24" descr="Une image contenant capture d’écran&#10;&#10;Le contenu généré par l’IA peut être incorrect.">
+            <a:extLst>
+              <a:ext uri="{FF2B5EF4-FFF2-40B4-BE49-F238E27FC236}">
+                <a16:creationId xmlns:a16="http://schemas.microsoft.com/office/drawing/2014/main" id="{8720E50D-9863-1B1C-73F2-6DEA99F9B174}"/>
+              </a:ext>
+            </a:extLst>
+          </p:cNvPr>
+          <p:cNvPicPr>
+            <a:picLocks noChangeAspect="1"/>
+          </p:cNvPicPr>
+          <p:nvPr/>
+        </p:nvPicPr>
+        <p:blipFill>
+          <a:blip r:embed="rId11">
+            <a:extLst>
+              <a:ext uri="{28A0092B-C50C-407E-A947-70E740481C1C}">
+                <a14:useLocalDpi xmlns:a14="http://schemas.microsoft.com/office/drawing/2010/main" val="0"/>
+              </a:ext>
+            </a:extLst>
+          </a:blip>
+          <a:stretch>
+            <a:fillRect/>
+          </a:stretch>
+        </p:blipFill>
+        <p:spPr>
+          <a:xfrm>
+            <a:off x="8707313" y="9595280"/>
+            <a:ext cx="5206884" cy="3938450"/>
+          </a:xfrm>
+          <a:prstGeom prst="rect">
+            <a:avLst/>
+          </a:prstGeom>
+        </p:spPr>
+      </p:pic>
+      <p:pic>
+        <p:nvPicPr>
+          <p:cNvPr id="27" name="Image 26" descr="Une image contenant capture d’écran, texte, ligne, Police&#10;&#10;Le contenu généré par l’IA peut être incorrect.">
+            <a:extLst>
+              <a:ext uri="{FF2B5EF4-FFF2-40B4-BE49-F238E27FC236}">
+                <a16:creationId xmlns:a16="http://schemas.microsoft.com/office/drawing/2014/main" id="{7AC5B4ED-21DD-FF3A-0DA8-C7E202FB1DF4}"/>
+              </a:ext>
+            </a:extLst>
+          </p:cNvPr>
+          <p:cNvPicPr>
+            <a:picLocks noChangeAspect="1"/>
+          </p:cNvPicPr>
+          <p:nvPr/>
+        </p:nvPicPr>
+        <p:blipFill>
+          <a:blip r:embed="rId12">
+            <a:extLst>
+              <a:ext uri="{28A0092B-C50C-407E-A947-70E740481C1C}">
+                <a14:useLocalDpi xmlns:a14="http://schemas.microsoft.com/office/drawing/2010/main" val="0"/>
+              </a:ext>
+            </a:extLst>
+          </a:blip>
+          <a:stretch>
+            <a:fillRect/>
+          </a:stretch>
+        </p:blipFill>
+        <p:spPr>
+          <a:xfrm>
+            <a:off x="7603224" y="13761294"/>
+            <a:ext cx="7299400" cy="758014"/>
+          </a:xfrm>
+          <a:prstGeom prst="rect">
+            <a:avLst/>
+          </a:prstGeom>
+        </p:spPr>
+      </p:pic>
+      <p:pic>
+        <p:nvPicPr>
+          <p:cNvPr id="34" name="Image 33" descr="Une image contenant Panneau de signalisation, signe&#10;&#10;Le contenu généré par l’IA peut être incorrect.">
+            <a:extLst>
+              <a:ext uri="{FF2B5EF4-FFF2-40B4-BE49-F238E27FC236}">
+                <a16:creationId xmlns:a16="http://schemas.microsoft.com/office/drawing/2014/main" id="{D2392334-9C70-F82D-A220-E87A656703A1}"/>
+              </a:ext>
+            </a:extLst>
+          </p:cNvPr>
+          <p:cNvPicPr>
+            <a:picLocks noChangeAspect="1"/>
+          </p:cNvPicPr>
+          <p:nvPr/>
+        </p:nvPicPr>
+        <p:blipFill>
+          <a:blip r:embed="rId13">
+            <a:extLst>
+              <a:ext uri="{28A0092B-C50C-407E-A947-70E740481C1C}">
+                <a14:useLocalDpi xmlns:a14="http://schemas.microsoft.com/office/drawing/2010/main" val="0"/>
+              </a:ext>
+            </a:extLst>
+          </a:blip>
+          <a:stretch>
+            <a:fillRect/>
+          </a:stretch>
+        </p:blipFill>
+        <p:spPr>
+          <a:xfrm>
+            <a:off x="7510051" y="15099766"/>
+            <a:ext cx="1827323" cy="1827323"/>
+          </a:xfrm>
+          <a:prstGeom prst="rect">
+            <a:avLst/>
+          </a:prstGeom>
+        </p:spPr>
+      </p:pic>
+      <mc:AlternateContent xmlns:mc="http://schemas.openxmlformats.org/markup-compatibility/2006" xmlns:a14="http://schemas.microsoft.com/office/drawing/2010/main">
+        <mc:Choice Requires="a14">
+          <p:sp>
+            <p:nvSpPr>
+              <p:cNvPr id="35" name="ZoneTexte 34">
+                <a:extLst>
+                  <a:ext uri="{FF2B5EF4-FFF2-40B4-BE49-F238E27FC236}">
+                    <a16:creationId xmlns:a16="http://schemas.microsoft.com/office/drawing/2014/main" id="{B692489C-6999-4008-6318-75D2BE9E4648}"/>
+                  </a:ext>
+                </a:extLst>
+              </p:cNvPr>
+              <p:cNvSpPr txBox="1"/>
+              <p:nvPr/>
+            </p:nvSpPr>
+            <p:spPr>
+              <a:xfrm>
+                <a:off x="9213008" y="15059661"/>
+                <a:ext cx="5378559" cy="1938992"/>
+              </a:xfrm>
+              <a:prstGeom prst="rect">
+                <a:avLst/>
+              </a:prstGeom>
+              <a:noFill/>
+            </p:spPr>
+            <p:txBody>
+              <a:bodyPr wrap="square" rtlCol="0">
+                <a:spAutoFit/>
+              </a:bodyPr>
+              <a:lstStyle/>
+              <a:p>
+                <a:r>
+                  <a:rPr lang="fr-FR" sz="2000" dirty="0">
+                    <a:solidFill>
+                      <a:srgbClr val="FF0000"/>
+                    </a:solidFill>
+                    <a:latin typeface="Grandview" panose="020B0502040204020203" pitchFamily="34" charset="0"/>
+                  </a:rPr>
+                  <a:t>Dépassement de la limite d’élasticité</a:t>
+                </a:r>
+              </a:p>
+              <a:p>
+                <a:r>
+                  <a:rPr lang="fr-FR" sz="2000" dirty="0">
+                    <a:solidFill>
+                      <a:srgbClr val="FF0000"/>
+                    </a:solidFill>
+                    <a:latin typeface="Grandview" panose="020B0502040204020203" pitchFamily="34" charset="0"/>
+                  </a:rPr>
+                  <a:t>pour une tension des câbles de 15 N</a:t>
+                </a:r>
+              </a:p>
+              <a:p>
+                <a14:m>
+                  <m:oMath xmlns:m="http://schemas.openxmlformats.org/officeDocument/2006/math">
+                    <m:r>
+                      <a:rPr lang="fr-FR" sz="2000" dirty="0" smtClean="0">
+                        <a:solidFill>
+                          <a:srgbClr val="FF0000"/>
+                        </a:solidFill>
+                        <a:latin typeface="Cambria Math" panose="02040503050406030204" pitchFamily="18" charset="0"/>
+                      </a:rPr>
+                      <m:t>⇒</m:t>
+                    </m:r>
+                    <m:r>
+                      <a:rPr lang="fr-FR" sz="2000" b="0" i="0" dirty="0" smtClean="0">
+                        <a:solidFill>
+                          <a:srgbClr val="FF0000"/>
+                        </a:solidFill>
+                        <a:latin typeface="Cambria Math" panose="02040503050406030204" pitchFamily="18" charset="0"/>
+                      </a:rPr>
+                      <m:t> </m:t>
+                    </m:r>
+                  </m:oMath>
+                </a14:m>
+                <a:r>
+                  <a:rPr lang="fr-FR" sz="2000" dirty="0">
+                    <a:solidFill>
+                      <a:srgbClr val="FF0000"/>
+                    </a:solidFill>
+                    <a:latin typeface="Grandview" panose="020B0502040204020203" pitchFamily="34" charset="0"/>
+                  </a:rPr>
+                  <a:t>le matériau se plastifie !</a:t>
+                </a:r>
+              </a:p>
+              <a:p>
+                <a:endParaRPr lang="fr-FR" sz="2000" dirty="0">
+                  <a:solidFill>
+                    <a:srgbClr val="FF0000"/>
+                  </a:solidFill>
+                  <a:latin typeface="Grandview" panose="020B0502040204020203" pitchFamily="34" charset="0"/>
+                </a:endParaRPr>
+              </a:p>
+              <a:p>
+                <a:pPr marL="342900" indent="-342900">
+                  <a:buFont typeface="Wingdings" panose="05000000000000000000" pitchFamily="2" charset="2"/>
+                  <a:buChar char="Ø"/>
+                </a:pPr>
+                <a:r>
+                  <a:rPr lang="fr-FR" sz="2000" dirty="0">
+                    <a:solidFill>
+                      <a:srgbClr val="FF0000"/>
+                    </a:solidFill>
+                    <a:latin typeface="Grandview" panose="020B0502040204020203" pitchFamily="34" charset="0"/>
+                  </a:rPr>
+                  <a:t>Ajout d’un élastique pour permettre le retour à la position droite.</a:t>
+                </a:r>
+              </a:p>
+            </p:txBody>
+          </p:sp>
+        </mc:Choice>
+        <mc:Fallback xmlns="">
+          <p:sp>
+            <p:nvSpPr>
+              <p:cNvPr id="35" name="ZoneTexte 34">
+                <a:extLst>
+                  <a:ext uri="{FF2B5EF4-FFF2-40B4-BE49-F238E27FC236}">
+                    <a16:creationId xmlns:a16="http://schemas.microsoft.com/office/drawing/2014/main" id="{B692489C-6999-4008-6318-75D2BE9E4648}"/>
+                  </a:ext>
+                </a:extLst>
+              </p:cNvPr>
+              <p:cNvSpPr txBox="1">
+                <a:spLocks noRot="1" noChangeAspect="1" noMove="1" noResize="1" noEditPoints="1" noAdjustHandles="1" noChangeArrowheads="1" noChangeShapeType="1" noTextEdit="1"/>
+              </p:cNvSpPr>
+              <p:nvPr/>
+            </p:nvSpPr>
+            <p:spPr>
+              <a:xfrm>
+                <a:off x="9213008" y="15059661"/>
+                <a:ext cx="5378559" cy="1938992"/>
+              </a:xfrm>
+              <a:prstGeom prst="rect">
+                <a:avLst/>
+              </a:prstGeom>
+              <a:blipFill>
+                <a:blip r:embed="rId14"/>
+                <a:stretch>
+                  <a:fillRect t="-1572" b="-4717"/>
+                </a:stretch>
+              </a:blipFill>
+            </p:spPr>
+            <p:txBody>
+              <a:bodyPr/>
+              <a:lstStyle/>
+              <a:p>
+                <a:r>
+                  <a:rPr lang="fr-FR">
+                    <a:noFill/>
+                  </a:rPr>
+                  <a:t> </a:t>
+                </a:r>
+              </a:p>
+            </p:txBody>
+          </p:sp>
+        </mc:Fallback>
+      </mc:AlternateContent>
+      <p:sp>
+        <p:nvSpPr>
+          <p:cNvPr id="36" name="Rectangle 35">
+            <a:extLst>
+              <a:ext uri="{FF2B5EF4-FFF2-40B4-BE49-F238E27FC236}">
+                <a16:creationId xmlns:a16="http://schemas.microsoft.com/office/drawing/2014/main" id="{EBF305C7-3B56-A639-5DDA-46A588EFA96A}"/>
+              </a:ext>
+            </a:extLst>
+          </p:cNvPr>
+          <p:cNvSpPr/>
+          <p:nvPr/>
+        </p:nvSpPr>
+        <p:spPr>
+          <a:xfrm>
+            <a:off x="377163" y="20151899"/>
+            <a:ext cx="14343981" cy="855895"/>
+          </a:xfrm>
+          <a:prstGeom prst="rect">
+            <a:avLst/>
+          </a:prstGeom>
+          <a:solidFill>
+            <a:schemeClr val="tx2"/>
+          </a:solidFill>
+          <a:ln>
+            <a:solidFill>
+              <a:schemeClr val="tx1"/>
+            </a:solidFill>
+          </a:ln>
+        </p:spPr>
+        <p:style>
+          <a:lnRef idx="2">
+            <a:schemeClr val="accent1">
+              <a:shade val="15000"/>
+            </a:schemeClr>
+          </a:lnRef>
+          <a:fillRef idx="1">
+            <a:schemeClr val="accent1"/>
+          </a:fillRef>
+          <a:effectRef idx="0">
+            <a:schemeClr val="accent1"/>
+          </a:effectRef>
+          <a:fontRef idx="minor">
+            <a:schemeClr val="lt1"/>
+          </a:fontRef>
+        </p:style>
+        <p:txBody>
+          <a:bodyPr rtlCol="0" anchor="ctr"/>
+          <a:lstStyle/>
+          <a:p>
+            <a:r>
+              <a:rPr lang="fr-FR" dirty="0">
+                <a:solidFill>
+                  <a:schemeClr val="bg1"/>
+                </a:solidFill>
+                <a:latin typeface="Grandview" panose="020B0502040204020203" pitchFamily="34" charset="0"/>
+              </a:rPr>
+              <a:t>Référence :</a:t>
+            </a:r>
+          </a:p>
+          <a:p>
+            <a:r>
+              <a:rPr lang="fr-FR" dirty="0">
+                <a:solidFill>
+                  <a:schemeClr val="bg1"/>
+                </a:solidFill>
+                <a:latin typeface="Grandview" panose="020B0502040204020203" pitchFamily="34" charset="0"/>
+              </a:rPr>
+              <a:t>[1] Z. Wang, N. M. </a:t>
+            </a:r>
+            <a:r>
+              <a:rPr lang="fr-FR" dirty="0" err="1">
+                <a:solidFill>
+                  <a:schemeClr val="bg1"/>
+                </a:solidFill>
+                <a:latin typeface="Grandview" panose="020B0502040204020203" pitchFamily="34" charset="0"/>
+              </a:rPr>
+              <a:t>Freris</a:t>
+            </a:r>
+            <a:r>
+              <a:rPr lang="fr-FR" dirty="0">
+                <a:solidFill>
+                  <a:schemeClr val="bg1"/>
+                </a:solidFill>
+                <a:latin typeface="Grandview" panose="020B0502040204020203" pitchFamily="34" charset="0"/>
+              </a:rPr>
+              <a:t>, and X. Wei, “</a:t>
+            </a:r>
+            <a:r>
+              <a:rPr lang="fr-FR" dirty="0" err="1">
+                <a:solidFill>
+                  <a:schemeClr val="bg1"/>
+                </a:solidFill>
+                <a:latin typeface="Grandview" panose="020B0502040204020203" pitchFamily="34" charset="0"/>
+              </a:rPr>
+              <a:t>SpiRobs</a:t>
+            </a:r>
+            <a:r>
+              <a:rPr lang="fr-FR" dirty="0">
+                <a:solidFill>
+                  <a:schemeClr val="bg1"/>
+                </a:solidFill>
+                <a:latin typeface="Grandview" panose="020B0502040204020203" pitchFamily="34" charset="0"/>
+              </a:rPr>
+              <a:t> : </a:t>
+            </a:r>
+            <a:r>
+              <a:rPr lang="fr-FR" dirty="0" err="1">
+                <a:solidFill>
+                  <a:schemeClr val="bg1"/>
+                </a:solidFill>
+                <a:latin typeface="Grandview" panose="020B0502040204020203" pitchFamily="34" charset="0"/>
+              </a:rPr>
+              <a:t>Logarithmic</a:t>
+            </a:r>
+            <a:r>
+              <a:rPr lang="fr-FR" dirty="0">
+                <a:solidFill>
+                  <a:schemeClr val="bg1"/>
+                </a:solidFill>
+                <a:latin typeface="Grandview" panose="020B0502040204020203" pitchFamily="34" charset="0"/>
+              </a:rPr>
+              <a:t> spiral-</a:t>
+            </a:r>
+            <a:r>
+              <a:rPr lang="fr-FR" dirty="0" err="1">
+                <a:solidFill>
+                  <a:schemeClr val="bg1"/>
+                </a:solidFill>
+                <a:latin typeface="Grandview" panose="020B0502040204020203" pitchFamily="34" charset="0"/>
+              </a:rPr>
+              <a:t>shaped</a:t>
+            </a:r>
+            <a:r>
+              <a:rPr lang="fr-FR" dirty="0">
+                <a:solidFill>
+                  <a:schemeClr val="bg1"/>
+                </a:solidFill>
+                <a:latin typeface="Grandview" panose="020B0502040204020203" pitchFamily="34" charset="0"/>
+              </a:rPr>
+              <a:t> robots for </a:t>
+            </a:r>
+            <a:r>
+              <a:rPr lang="fr-FR" dirty="0" err="1">
+                <a:solidFill>
+                  <a:schemeClr val="bg1"/>
+                </a:solidFill>
+                <a:latin typeface="Grandview" panose="020B0502040204020203" pitchFamily="34" charset="0"/>
+              </a:rPr>
+              <a:t>versatilegrasping</a:t>
+            </a:r>
+            <a:r>
+              <a:rPr lang="fr-FR" dirty="0">
+                <a:solidFill>
+                  <a:schemeClr val="bg1"/>
+                </a:solidFill>
+                <a:latin typeface="Grandview" panose="020B0502040204020203" pitchFamily="34" charset="0"/>
+              </a:rPr>
+              <a:t> </a:t>
+            </a:r>
+            <a:r>
+              <a:rPr lang="fr-FR" dirty="0" err="1">
+                <a:solidFill>
+                  <a:schemeClr val="bg1"/>
+                </a:solidFill>
+                <a:latin typeface="Grandview" panose="020B0502040204020203" pitchFamily="34" charset="0"/>
+              </a:rPr>
+              <a:t>across</a:t>
+            </a:r>
+            <a:r>
+              <a:rPr lang="fr-FR" dirty="0">
+                <a:solidFill>
+                  <a:schemeClr val="bg1"/>
+                </a:solidFill>
+                <a:latin typeface="Grandview" panose="020B0502040204020203" pitchFamily="34" charset="0"/>
+              </a:rPr>
+              <a:t> </a:t>
+            </a:r>
+            <a:r>
+              <a:rPr lang="fr-FR" dirty="0" err="1">
+                <a:solidFill>
+                  <a:schemeClr val="bg1"/>
+                </a:solidFill>
+                <a:latin typeface="Grandview" panose="020B0502040204020203" pitchFamily="34" charset="0"/>
+              </a:rPr>
+              <a:t>scales</a:t>
+            </a:r>
+            <a:r>
+              <a:rPr lang="fr-FR" dirty="0">
+                <a:solidFill>
+                  <a:schemeClr val="bg1"/>
+                </a:solidFill>
+                <a:latin typeface="Grandview" panose="020B0502040204020203" pitchFamily="34" charset="0"/>
+              </a:rPr>
+              <a:t>,” </a:t>
+            </a:r>
+            <a:r>
+              <a:rPr lang="fr-FR" dirty="0" err="1">
+                <a:solidFill>
+                  <a:schemeClr val="bg1"/>
+                </a:solidFill>
+                <a:latin typeface="Grandview" panose="020B0502040204020203" pitchFamily="34" charset="0"/>
+              </a:rPr>
+              <a:t>Device</a:t>
+            </a:r>
+            <a:r>
+              <a:rPr lang="fr-FR" dirty="0">
+                <a:solidFill>
+                  <a:schemeClr val="bg1"/>
+                </a:solidFill>
+                <a:latin typeface="Grandview" panose="020B0502040204020203" pitchFamily="34" charset="0"/>
+              </a:rPr>
+              <a:t>, vol. 3, no. 4, Apr. 2025, </a:t>
+            </a:r>
+            <a:r>
+              <a:rPr lang="fr-FR" dirty="0" err="1">
+                <a:solidFill>
+                  <a:schemeClr val="bg1"/>
+                </a:solidFill>
+                <a:latin typeface="Grandview" panose="020B0502040204020203" pitchFamily="34" charset="0"/>
+              </a:rPr>
+              <a:t>publisher</a:t>
+            </a:r>
+            <a:r>
+              <a:rPr lang="fr-FR" dirty="0">
+                <a:solidFill>
+                  <a:schemeClr val="bg1"/>
+                </a:solidFill>
+                <a:latin typeface="Grandview" panose="020B0502040204020203" pitchFamily="34" charset="0"/>
+              </a:rPr>
+              <a:t> : Elsevier. [Online]. </a:t>
+            </a:r>
+            <a:r>
+              <a:rPr lang="fr-FR" dirty="0" err="1">
+                <a:solidFill>
+                  <a:schemeClr val="bg1"/>
+                </a:solidFill>
+                <a:latin typeface="Grandview" panose="020B0502040204020203" pitchFamily="34" charset="0"/>
+              </a:rPr>
+              <a:t>Available</a:t>
+            </a:r>
+            <a:r>
+              <a:rPr lang="fr-FR" dirty="0">
+                <a:solidFill>
+                  <a:schemeClr val="bg1"/>
+                </a:solidFill>
+                <a:latin typeface="Grandview" panose="020B0502040204020203" pitchFamily="34" charset="0"/>
+              </a:rPr>
+              <a:t> :https://www.cell.com/device/abstract/S2666-9986(24)00603-3</a:t>
+            </a:r>
+          </a:p>
+        </p:txBody>
+      </p:sp>
+      <p:sp>
+        <p:nvSpPr>
+          <p:cNvPr id="37" name="ZoneTexte 36">
+            <a:extLst>
+              <a:ext uri="{FF2B5EF4-FFF2-40B4-BE49-F238E27FC236}">
+                <a16:creationId xmlns:a16="http://schemas.microsoft.com/office/drawing/2014/main" id="{93D53B09-F734-2CD2-A0FF-FA44CE0A3A64}"/>
+              </a:ext>
+            </a:extLst>
+          </p:cNvPr>
+          <p:cNvSpPr txBox="1"/>
+          <p:nvPr/>
+        </p:nvSpPr>
+        <p:spPr>
+          <a:xfrm>
+            <a:off x="6949196" y="8591139"/>
+            <a:ext cx="450764" cy="369332"/>
+          </a:xfrm>
+          <a:prstGeom prst="rect">
+            <a:avLst/>
+          </a:prstGeom>
+          <a:noFill/>
+        </p:spPr>
+        <p:txBody>
+          <a:bodyPr wrap="none" rtlCol="0">
+            <a:spAutoFit/>
+          </a:bodyPr>
+          <a:lstStyle/>
+          <a:p>
+            <a:r>
+              <a:rPr lang="fr-FR" b="1" dirty="0">
+                <a:latin typeface="Grandview" panose="020B0502040204020203" pitchFamily="34" charset="0"/>
+              </a:rPr>
+              <a:t>[1]</a:t>
+            </a:r>
+          </a:p>
+        </p:txBody>
+      </p:sp>
+      <p:sp>
+        <p:nvSpPr>
+          <p:cNvPr id="41" name="Forme libre : forme 40">
+            <a:extLst>
+              <a:ext uri="{FF2B5EF4-FFF2-40B4-BE49-F238E27FC236}">
+                <a16:creationId xmlns:a16="http://schemas.microsoft.com/office/drawing/2014/main" id="{8A879908-B1D8-5540-1276-492476E3E355}"/>
+              </a:ext>
+            </a:extLst>
+          </p:cNvPr>
+          <p:cNvSpPr/>
+          <p:nvPr/>
+        </p:nvSpPr>
+        <p:spPr>
+          <a:xfrm>
+            <a:off x="5003391" y="17662019"/>
+            <a:ext cx="9717753" cy="758014"/>
+          </a:xfrm>
+          <a:custGeom>
+            <a:avLst/>
+            <a:gdLst>
+              <a:gd name="connsiteX0" fmla="*/ 0 w 8214454"/>
+              <a:gd name="connsiteY0" fmla="*/ 126583 h 1193383"/>
+              <a:gd name="connsiteX1" fmla="*/ 6400800 w 8214454"/>
+              <a:gd name="connsiteY1" fmla="*/ 96103 h 1193383"/>
+              <a:gd name="connsiteX2" fmla="*/ 8214360 w 8214454"/>
+              <a:gd name="connsiteY2" fmla="*/ 1193383 h 1193383"/>
+            </a:gdLst>
+            <a:ahLst/>
+            <a:cxnLst>
+              <a:cxn ang="0">
+                <a:pos x="connsiteX0" y="connsiteY0"/>
+              </a:cxn>
+              <a:cxn ang="0">
+                <a:pos x="connsiteX1" y="connsiteY1"/>
+              </a:cxn>
+              <a:cxn ang="0">
+                <a:pos x="connsiteX2" y="connsiteY2"/>
+              </a:cxn>
+            </a:cxnLst>
+            <a:rect l="l" t="t" r="r" b="b"/>
+            <a:pathLst>
+              <a:path w="8214454" h="1193383">
+                <a:moveTo>
+                  <a:pt x="0" y="126583"/>
+                </a:moveTo>
+                <a:cubicBezTo>
+                  <a:pt x="2515870" y="22443"/>
+                  <a:pt x="5031740" y="-81697"/>
+                  <a:pt x="6400800" y="96103"/>
+                </a:cubicBezTo>
+                <a:cubicBezTo>
+                  <a:pt x="7769860" y="273903"/>
+                  <a:pt x="8221980" y="964783"/>
+                  <a:pt x="8214360" y="1193383"/>
+                </a:cubicBezTo>
+              </a:path>
+            </a:pathLst>
+          </a:custGeom>
+          <a:noFill/>
+        </p:spPr>
+        <p:style>
+          <a:lnRef idx="2">
+            <a:schemeClr val="accent1">
+              <a:shade val="15000"/>
+            </a:schemeClr>
+          </a:lnRef>
+          <a:fillRef idx="1">
+            <a:schemeClr val="accent1"/>
+          </a:fillRef>
+          <a:effectRef idx="0">
+            <a:schemeClr val="accent1"/>
+          </a:effectRef>
+          <a:fontRef idx="minor">
+            <a:schemeClr val="lt1"/>
+          </a:fontRef>
+        </p:style>
+        <p:txBody>
+          <a:bodyPr rtlCol="0" anchor="ctr"/>
+          <a:lstStyle/>
+          <a:p>
+            <a:pPr algn="ctr"/>
+            <a:endParaRPr lang="fr-FR"/>
+          </a:p>
+        </p:txBody>
+      </p:sp>
+      <p:sp>
+        <p:nvSpPr>
+          <p:cNvPr id="42" name="ZoneTexte 41">
+            <a:extLst>
+              <a:ext uri="{FF2B5EF4-FFF2-40B4-BE49-F238E27FC236}">
+                <a16:creationId xmlns:a16="http://schemas.microsoft.com/office/drawing/2014/main" id="{095C6D14-6876-F156-24AD-C767534F60A2}"/>
+              </a:ext>
+            </a:extLst>
+          </p:cNvPr>
+          <p:cNvSpPr txBox="1"/>
+          <p:nvPr/>
+        </p:nvSpPr>
+        <p:spPr>
+          <a:xfrm>
+            <a:off x="453183" y="18516661"/>
+            <a:ext cx="14212983" cy="2246769"/>
+          </a:xfrm>
+          <a:prstGeom prst="rect">
+            <a:avLst/>
+          </a:prstGeom>
+          <a:noFill/>
+        </p:spPr>
+        <p:txBody>
+          <a:bodyPr wrap="square" rtlCol="0">
+            <a:spAutoFit/>
+          </a:bodyPr>
+          <a:lstStyle/>
+          <a:p>
+            <a:pPr algn="just"/>
+            <a:r>
+              <a:rPr lang="fr-FR" sz="2000" dirty="0">
+                <a:latin typeface="Grandview" panose="020B0502040204020203" pitchFamily="34" charset="0"/>
+              </a:rPr>
+              <a:t>Ce projet nous a permis de maîtriser le module de simulation par éléments finis, </a:t>
+            </a:r>
+            <a:r>
+              <a:rPr lang="fr-FR" sz="2000" i="1" dirty="0">
+                <a:latin typeface="Grandview" panose="020B0502040204020203" pitchFamily="34" charset="0"/>
+              </a:rPr>
+              <a:t>SolidWorks Simulation</a:t>
+            </a:r>
+            <a:r>
+              <a:rPr lang="fr-FR" sz="2000" dirty="0">
+                <a:latin typeface="Grandview" panose="020B0502040204020203" pitchFamily="34" charset="0"/>
+              </a:rPr>
+              <a:t>, et il nous a offert une expérience approfondie dans la conception d’un assemblage. De plus, il nous a permis d’explorer la robotique souple, d’en détailler les avantages, notamment l’adaptabilité aux formes irrégulières, et les limites, comme la faible capacité de charge. Enfin, ce projet nous a offert l’opportunité de concevoir un système d’actionnement par câbles, renforçant notre compréhension des mécanismes de transmission de couples dans les systèmes robotiques.</a:t>
+            </a:r>
+          </a:p>
+          <a:p>
+            <a:pPr algn="just"/>
+            <a:endParaRPr lang="fr-FR" sz="2000" dirty="0">
+              <a:latin typeface="Grandview" panose="020B0502040204020203" pitchFamily="34" charset="0"/>
+            </a:endParaRPr>
+          </a:p>
+          <a:p>
+            <a:pPr algn="just"/>
+            <a:endParaRPr lang="fr-FR" sz="2000" dirty="0">
+              <a:latin typeface="Grandview" panose="020B0502040204020203" pitchFamily="34" charset="0"/>
+            </a:endParaRPr>
+          </a:p>
+        </p:txBody>
+      </p:sp>
+      <p:pic>
+        <p:nvPicPr>
+          <p:cNvPr id="16" name="Image 15" descr="Une image contenant jouet, arme&#10;&#10;Le contenu généré par l’IA peut être incorrect.">
+            <a:extLst>
+              <a:ext uri="{FF2B5EF4-FFF2-40B4-BE49-F238E27FC236}">
+                <a16:creationId xmlns:a16="http://schemas.microsoft.com/office/drawing/2014/main" id="{C90CFCDC-A272-F16A-C5CB-A521D8DC8DA0}"/>
+              </a:ext>
+            </a:extLst>
+          </p:cNvPr>
+          <p:cNvPicPr>
+            <a:picLocks noChangeAspect="1"/>
+          </p:cNvPicPr>
+          <p:nvPr/>
+        </p:nvPicPr>
+        <p:blipFill>
+          <a:blip r:embed="rId15">
+            <a:extLst>
+              <a:ext uri="{28A0092B-C50C-407E-A947-70E740481C1C}">
+                <a14:useLocalDpi xmlns:a14="http://schemas.microsoft.com/office/drawing/2010/main" val="0"/>
+              </a:ext>
+            </a:extLst>
+          </a:blip>
+          <a:stretch>
+            <a:fillRect/>
+          </a:stretch>
+        </p:blipFill>
+        <p:spPr>
+          <a:xfrm>
+            <a:off x="1511931" y="8988618"/>
+            <a:ext cx="4704633" cy="2648159"/>
+          </a:xfrm>
+          <a:prstGeom prst="rect">
+            <a:avLst/>
+          </a:prstGeom>
+        </p:spPr>
+      </p:pic>
     </p:spTree>
   </p:cSld>
   <p:clrMapOvr>

</xml_diff>